<commit_message>
Report review fixes: road-test counts on unique records, 21 Oct faults, verdicts, stale text, evidence rows; deck and poster updated
</commit_message>
<xml_diff>
--- a/Presentation/SW7_Final_Presentation.pptx
+++ b/Presentation/SW7_Final_Presentation.pptx
@@ -1139,7 +1139,7 @@
           <a:p>
             <a:r>
               <a:rPr lang="en-US" dirty="0"/>
-              <a:t>On the nineteenth of October the whole system was mounted and the first road session run. A recorder on the Pi 5 captured all four sources for 108.6 minutes, about 19.5 of them driving, with no laptop on board. Both IMUs held 200 hertz with no drops, so R1 is met on the vehicle. The battery link held under load: up to 46.9 amps, the pack falling from 74.6 to 72.8 volts. The cameras raised 1,342 front and 741 rear alerts, not yet checked against video. But GNSS had no fix, and there were no raw samples or run markers, so RQ1 and RQ4 are not answered yet. A second, shorter session is planned.</a:t>
+              <a:t>On the nineteenth of October the whole system was mounted and the first road session run. A recorder on the Pi 5 ran for 108.6 minutes, about 16 of them driving, with no laptop on board. Both IMUs held 200 hertz with no drops and one short stall, but a third of the per-second records were lost on the USB link, now replaced by wires, so R1 is only partly met on the vehicle. The battery link held under load: up to 46.9 amps, the pack falling from 74.6 to 72.8 volts. The cameras raised 1,342 front and 741 rear alerts, not yet checked against video. But GNSS had no fix, as no antenna was fitted, and there were no raw samples or run markers, so RQ1 and RQ4 are not answered yet. A second, shorter session is planned.</a:t>
             </a:r>
             <a:endParaRPr lang="en-US" dirty="0"/>
           </a:p>
@@ -2306,7 +2306,7 @@
       </p:grpSpPr>
       <p:pic>
         <p:nvPicPr>
-          <p:cNvPr id="2" name="Image 0" descr="C:\Users\0geda\OneDrive - University of Cape Town\Documents\PlatformIO\Projects\Tukzie-HPEC-HUD\.claude\worktrees\agent-ad83ea5807b9a7552\Presentation\source\assets\uct_banner.jpg">    </p:cNvPr>
+          <p:cNvPr id="2" name="Image 0" descr="C:\Users\0geda\OneDrive - University of Cape Town\Documents\PlatformIO\Projects\Tukzie-HPEC-HUD\Presentation\source\assets\uct_banner.jpg">    </p:cNvPr>
           <p:cNvPicPr>
             <a:picLocks noChangeAspect="1"/>
           </p:cNvPicPr>
@@ -2665,7 +2665,7 @@
       </p:sp>
       <p:pic>
         <p:nvPicPr>
-          <p:cNvPr id="5" name="Image 0" descr="C:\Users\0geda\OneDrive - University of Cape Town\Documents\PlatformIO\Projects\Tukzie-HPEC-HUD\.claude\worktrees\agent-ad83ea5807b9a7552\Presentation\source\assets\uct_logo.png">    </p:cNvPr>
+          <p:cNvPr id="5" name="Image 0" descr="C:\Users\0geda\OneDrive - University of Cape Town\Documents\PlatformIO\Projects\Tukzie-HPEC-HUD\Presentation\source\assets\uct_logo.png">    </p:cNvPr>
           <p:cNvPicPr>
             <a:picLocks noChangeAspect="1"/>
           </p:cNvPicPr>
@@ -3599,7 +3599,7 @@
       </p:sp>
       <p:pic>
         <p:nvPicPr>
-          <p:cNvPr id="5" name="Image 0" descr="C:\Users\0geda\OneDrive - University of Cape Town\Documents\PlatformIO\Projects\Tukzie-HPEC-HUD\.claude\worktrees\agent-ad83ea5807b9a7552\Presentation\source\assets\uct_logo.png">    </p:cNvPr>
+          <p:cNvPr id="5" name="Image 0" descr="C:\Users\0geda\OneDrive - University of Cape Town\Documents\PlatformIO\Projects\Tukzie-HPEC-HUD\Presentation\source\assets\uct_logo.png">    </p:cNvPr>
           <p:cNvPicPr>
             <a:picLocks noChangeAspect="1"/>
           </p:cNvPicPr>
@@ -3701,7 +3701,7 @@
       </p:sp>
       <p:pic>
         <p:nvPicPr>
-          <p:cNvPr id="9" name="Image 1" descr="C:\Users\0geda\OneDrive - University of Cape Town\Documents\PlatformIO\Projects\Tukzie-HPEC-HUD\.claude\worktrees\agent-ad83ea5807b9a7552\Report\figures\ui\ui_dualcam_front.png">    </p:cNvPr>
+          <p:cNvPr id="9" name="Image 1" descr="C:\Users\0geda\OneDrive - University of Cape Town\Documents\PlatformIO\Projects\Tukzie-HPEC-HUD\Report\figures\ui\ui_dualcam_front.png">    </p:cNvPr>
           <p:cNvPicPr>
             <a:picLocks noChangeAspect="1"/>
           </p:cNvPicPr>
@@ -3725,7 +3725,7 @@
       </p:pic>
       <p:pic>
         <p:nvPicPr>
-          <p:cNvPr id="10" name="Image 2" descr="C:\Users\0geda\OneDrive - University of Cape Town\Documents\PlatformIO\Projects\Tukzie-HPEC-HUD\.claude\worktrees\agent-ad83ea5807b9a7552\Report\figures\ui\ui_dualcam_rear_approaching.png">    </p:cNvPr>
+          <p:cNvPr id="10" name="Image 2" descr="C:\Users\0geda\OneDrive - University of Cape Town\Documents\PlatformIO\Projects\Tukzie-HPEC-HUD\Report\figures\ui\ui_dualcam_rear_approaching.png">    </p:cNvPr>
           <p:cNvPicPr>
             <a:picLocks noChangeAspect="1"/>
           </p:cNvPicPr>
@@ -4065,7 +4065,7 @@
       </p:sp>
       <p:pic>
         <p:nvPicPr>
-          <p:cNvPr id="18" name="Image 3" descr="C:\Users\0geda\OneDrive - University of Cape Town\Documents\PlatformIO\Projects\Tukzie-HPEC-HUD\.claude\worktrees\agent-ad83ea5807b9a7552\Report\figures\ui\ui_pi5_live_dualcam.png">    </p:cNvPr>
+          <p:cNvPr id="18" name="Image 3" descr="C:\Users\0geda\OneDrive - University of Cape Town\Documents\PlatformIO\Projects\Tukzie-HPEC-HUD\Report\figures\ui\ui_pi5_live_dualcam.png">    </p:cNvPr>
           <p:cNvPicPr>
             <a:picLocks noChangeAspect="1"/>
           </p:cNvPicPr>
@@ -4380,7 +4380,7 @@
       </p:sp>
       <p:pic>
         <p:nvPicPr>
-          <p:cNvPr id="5" name="Image 0" descr="C:\Users\0geda\OneDrive - University of Cape Town\Documents\PlatformIO\Projects\Tukzie-HPEC-HUD\.claude\worktrees\agent-ad83ea5807b9a7552\Presentation\source\assets\uct_logo.png">    </p:cNvPr>
+          <p:cNvPr id="5" name="Image 0" descr="C:\Users\0geda\OneDrive - University of Cape Town\Documents\PlatformIO\Projects\Tukzie-HPEC-HUD\Presentation\source\assets\uct_logo.png">    </p:cNvPr>
           <p:cNvPicPr>
             <a:picLocks noChangeAspect="1"/>
           </p:cNvPicPr>
@@ -4509,7 +4509,7 @@
       </p:sp>
       <p:pic>
         <p:nvPicPr>
-          <p:cNvPr id="10" name="Image 1" descr="C:\Users\0geda\OneDrive - University of Cape Town\Documents\PlatformIO\Projects\Tukzie-HPEC-HUD\.claude\worktrees\agent-ad83ea5807b9a7552\Presentation\source\assets\cad_front_pod.png">    </p:cNvPr>
+          <p:cNvPr id="10" name="Image 1" descr="C:\Users\0geda\OneDrive - University of Cape Town\Documents\PlatformIO\Projects\Tukzie-HPEC-HUD\Presentation\source\assets\cad_front_pod.png">    </p:cNvPr>
           <p:cNvPicPr>
             <a:picLocks noChangeAspect="1"/>
           </p:cNvPicPr>
@@ -4599,7 +4599,7 @@
       </p:sp>
       <p:pic>
         <p:nvPicPr>
-          <p:cNvPr id="13" name="Image 2" descr="C:\Users\0geda\OneDrive - University of Cape Town\Documents\PlatformIO\Projects\Tukzie-HPEC-HUD\.claude\worktrees\agent-ad83ea5807b9a7552\Presentation\source\assets\cad_display_mount.png">    </p:cNvPr>
+          <p:cNvPr id="13" name="Image 2" descr="C:\Users\0geda\OneDrive - University of Cape Town\Documents\PlatformIO\Projects\Tukzie-HPEC-HUD\Presentation\source\assets\cad_display_mount.png">    </p:cNvPr>
           <p:cNvPicPr>
             <a:picLocks noChangeAspect="1"/>
           </p:cNvPicPr>
@@ -4689,7 +4689,7 @@
       </p:sp>
       <p:pic>
         <p:nvPicPr>
-          <p:cNvPr id="16" name="Image 3" descr="C:\Users\0geda\OneDrive - University of Cape Town\Documents\PlatformIO\Projects\Tukzie-HPEC-HUD\.claude\worktrees\agent-ad83ea5807b9a7552\Presentation\source\assets\cad_vented_lid.png">    </p:cNvPr>
+          <p:cNvPr id="16" name="Image 3" descr="C:\Users\0geda\OneDrive - University of Cape Town\Documents\PlatformIO\Projects\Tukzie-HPEC-HUD\Presentation\source\assets\cad_vented_lid.png">    </p:cNvPr>
           <p:cNvPicPr>
             <a:picLocks noChangeAspect="1"/>
           </p:cNvPicPr>
@@ -4779,7 +4779,7 @@
       </p:sp>
       <p:pic>
         <p:nvPicPr>
-          <p:cNvPr id="19" name="Image 4" descr="C:\Users\0geda\OneDrive - University of Cape Town\Documents\PlatformIO\Projects\Tukzie-HPEC-HUD\.claude\worktrees\agent-ad83ea5807b9a7552\Presentation\source\assets\cad_front_pod_inside.png">    </p:cNvPr>
+          <p:cNvPr id="19" name="Image 4" descr="C:\Users\0geda\OneDrive - University of Cape Town\Documents\PlatformIO\Projects\Tukzie-HPEC-HUD\Presentation\source\assets\cad_front_pod_inside.png">    </p:cNvPr>
           <p:cNvPicPr>
             <a:picLocks noChangeAspect="1"/>
           </p:cNvPicPr>
@@ -5266,7 +5266,7 @@
       </p:sp>
       <p:pic>
         <p:nvPicPr>
-          <p:cNvPr id="5" name="Image 0" descr="C:\Users\0geda\OneDrive - University of Cape Town\Documents\PlatformIO\Projects\Tukzie-HPEC-HUD\.claude\worktrees\agent-ad83ea5807b9a7552\Presentation\source\assets\uct_logo.png">    </p:cNvPr>
+          <p:cNvPr id="5" name="Image 0" descr="C:\Users\0geda\OneDrive - University of Cape Town\Documents\PlatformIO\Projects\Tukzie-HPEC-HUD\Presentation\source\assets\uct_logo.png">    </p:cNvPr>
           <p:cNvPicPr>
             <a:picLocks noChangeAspect="1"/>
           </p:cNvPicPr>
@@ -5465,7 +5465,7 @@
                 <a:ea typeface="Calibri" pitchFamily="34" charset="-122"/>
                 <a:cs typeface="Calibri" pitchFamily="34" charset="-120"/>
               </a:rPr>
-              <a:t>recorded on the vehicle by the Pi 5, about 19.5 min of it driving</a:t>
+              <a:t>recorded on the vehicle by the Pi 5, about 16 min of it driving</a:t>
             </a:r>
             <a:endParaRPr lang="en-US" sz="1400" dirty="0"/>
           </a:p>
@@ -5570,7 +5570,7 @@
                 <a:ea typeface="Calibri" pitchFamily="34" charset="-122"/>
                 <a:cs typeface="Calibri" pitchFamily="34" charset="-120"/>
               </a:rPr>
-              <a:t>both IMUs, no drops in 10,287 records: R1 met on the vehicle</a:t>
+              <a:t>both IMUs, no drops, one 2 s stall; 38 % of records lost on USB: R1 partly met</a:t>
             </a:r>
             <a:endParaRPr lang="en-US" sz="1400" dirty="0"/>
           </a:p>
@@ -5675,7 +5675,7 @@
                 <a:ea typeface="Calibri" pitchFamily="34" charset="-122"/>
                 <a:cs typeface="Calibri" pitchFamily="34" charset="-120"/>
               </a:rPr>
-              <a:t>peak battery current; 74.6 to 72.8 V, 60 to 58 %: R5 met except the meter check</a:t>
+              <a:t>peak battery current; 74.6 to 72.8 V, 60 to 58 %: R5 partly met (no meter check)</a:t>
             </a:r>
             <a:endParaRPr lang="en-US" sz="1400" dirty="0"/>
           </a:p>
@@ -5819,7 +5819,7 @@
                 <a:ea typeface="Calibri" pitchFamily="34" charset="-122"/>
                 <a:cs typeface="Calibri" pitchFamily="34" charset="-120"/>
               </a:rPr>
-              <a:t>Parked and driving separate clearly: one-second vibration median 0.031 parked; 95th percentile 2.0, maximum 5.09 while driving.</a:t>
+              <a:t>Parked and driving separate clearly: one-second vibration median 0.03 parked; while driving median 1.39, 95th percentile 3.1, maximum 5.09.</a:t>
             </a:r>
             <a:endParaRPr lang="en-US" sz="1200" dirty="0"/>
           </a:p>
@@ -5928,7 +5928,7 @@
                 <a:ea typeface="Calibri" pitchFamily="34" charset="-122"/>
                 <a:cs typeface="Calibri" pitchFamily="34" charset="-120"/>
               </a:rPr>
-              <a:t>No GNSS fix in any record: R4 not met on the vehicle, and no speed</a:t>
+              <a:t>No GNSS fix in any record (no antenna fitted): R4 untested on the vehicle, and no speed</a:t>
             </a:r>
             <a:endParaRPr lang="en-US" sz="1500" dirty="0"/>
           </a:p>
@@ -6155,7 +6155,7 @@
       </p:sp>
       <p:pic>
         <p:nvPicPr>
-          <p:cNvPr id="5" name="Image 0" descr="C:\Users\0geda\OneDrive - University of Cape Town\Documents\PlatformIO\Projects\Tukzie-HPEC-HUD\.claude\worktrees\agent-ad83ea5807b9a7552\Presentation\source\assets\uct_logo.png">    </p:cNvPr>
+          <p:cNvPr id="5" name="Image 0" descr="C:\Users\0geda\OneDrive - University of Cape Town\Documents\PlatformIO\Projects\Tukzie-HPEC-HUD\Presentation\source\assets\uct_logo.png">    </p:cNvPr>
           <p:cNvPicPr>
             <a:picLocks noChangeAspect="1"/>
           </p:cNvPicPr>
@@ -6838,7 +6838,7 @@
       </p:sp>
       <p:pic>
         <p:nvPicPr>
-          <p:cNvPr id="5" name="Image 0" descr="C:\Users\0geda\OneDrive - University of Cape Town\Documents\PlatformIO\Projects\Tukzie-HPEC-HUD\.claude\worktrees\agent-ad83ea5807b9a7552\Presentation\source\assets\uct_logo.png">    </p:cNvPr>
+          <p:cNvPr id="5" name="Image 0" descr="C:\Users\0geda\OneDrive - University of Cape Town\Documents\PlatformIO\Projects\Tukzie-HPEC-HUD\Presentation\source\assets\uct_logo.png">    </p:cNvPr>
           <p:cNvPicPr>
             <a:picLocks noChangeAspect="1"/>
           </p:cNvPicPr>
@@ -7416,7 +7416,7 @@
       </p:sp>
       <p:pic>
         <p:nvPicPr>
-          <p:cNvPr id="5" name="Image 0" descr="C:\Users\0geda\OneDrive - University of Cape Town\Documents\PlatformIO\Projects\Tukzie-HPEC-HUD\.claude\worktrees\agent-ad83ea5807b9a7552\Presentation\source\assets\uct_logo.png">    </p:cNvPr>
+          <p:cNvPr id="5" name="Image 0" descr="C:\Users\0geda\OneDrive - University of Cape Town\Documents\PlatformIO\Projects\Tukzie-HPEC-HUD\Presentation\source\assets\uct_logo.png">    </p:cNvPr>
           <p:cNvPicPr>
             <a:picLocks noChangeAspect="1"/>
           </p:cNvPicPr>
@@ -8337,7 +8337,7 @@
       </p:sp>
       <p:pic>
         <p:nvPicPr>
-          <p:cNvPr id="5" name="Image 0" descr="C:\Users\0geda\OneDrive - University of Cape Town\Documents\PlatformIO\Projects\Tukzie-HPEC-HUD\.claude\worktrees\agent-ad83ea5807b9a7552\Presentation\source\assets\uct_logo.png">    </p:cNvPr>
+          <p:cNvPr id="5" name="Image 0" descr="C:\Users\0geda\OneDrive - University of Cape Town\Documents\PlatformIO\Projects\Tukzie-HPEC-HUD\Presentation\source\assets\uct_logo.png">    </p:cNvPr>
           <p:cNvPicPr>
             <a:picLocks noChangeAspect="1"/>
           </p:cNvPicPr>
@@ -9152,7 +9152,7 @@
       </p:sp>
       <p:pic>
         <p:nvPicPr>
-          <p:cNvPr id="5" name="Image 0" descr="C:\Users\0geda\OneDrive - University of Cape Town\Documents\PlatformIO\Projects\Tukzie-HPEC-HUD\.claude\worktrees\agent-ad83ea5807b9a7552\Presentation\source\assets\uct_logo.png">    </p:cNvPr>
+          <p:cNvPr id="5" name="Image 0" descr="C:\Users\0geda\OneDrive - University of Cape Town\Documents\PlatformIO\Projects\Tukzie-HPEC-HUD\Presentation\source\assets\uct_logo.png">    </p:cNvPr>
           <p:cNvPicPr>
             <a:picLocks noChangeAspect="1"/>
           </p:cNvPicPr>
@@ -10808,7 +10808,7 @@
       </p:sp>
       <p:pic>
         <p:nvPicPr>
-          <p:cNvPr id="5" name="Image 0" descr="C:\Users\0geda\OneDrive - University of Cape Town\Documents\PlatformIO\Projects\Tukzie-HPEC-HUD\.claude\worktrees\agent-ad83ea5807b9a7552\Presentation\source\assets\uct_logo.png">    </p:cNvPr>
+          <p:cNvPr id="5" name="Image 0" descr="C:\Users\0geda\OneDrive - University of Cape Town\Documents\PlatformIO\Projects\Tukzie-HPEC-HUD\Presentation\source\assets\uct_logo.png">    </p:cNvPr>
           <p:cNvPicPr>
             <a:picLocks noChangeAspect="1"/>
           </p:cNvPicPr>
@@ -11330,7 +11330,7 @@
       </p:sp>
       <p:pic>
         <p:nvPicPr>
-          <p:cNvPr id="21" name="Image 1" descr="C:\Users\0geda\OneDrive - University of Cape Town\Documents\PlatformIO\Projects\Tukzie-HPEC-HUD\.claude\worktrees\agent-ad83ea5807b9a7552\Presentation\source\assets\vibration_chart.png">    </p:cNvPr>
+          <p:cNvPr id="21" name="Image 1" descr="C:\Users\0geda\OneDrive - University of Cape Town\Documents\PlatformIO\Projects\Tukzie-HPEC-HUD\Presentation\source\assets\vibration_chart.png">    </p:cNvPr>
           <p:cNvPicPr>
             <a:picLocks noChangeAspect="1"/>
           </p:cNvPicPr>
@@ -11742,7 +11742,7 @@
       </p:sp>
       <p:pic>
         <p:nvPicPr>
-          <p:cNvPr id="5" name="Image 0" descr="C:\Users\0geda\OneDrive - University of Cape Town\Documents\PlatformIO\Projects\Tukzie-HPEC-HUD\.claude\worktrees\agent-ad83ea5807b9a7552\Presentation\source\assets\uct_logo.png">    </p:cNvPr>
+          <p:cNvPr id="5" name="Image 0" descr="C:\Users\0geda\OneDrive - University of Cape Town\Documents\PlatformIO\Projects\Tukzie-HPEC-HUD\Presentation\source\assets\uct_logo.png">    </p:cNvPr>
           <p:cNvPicPr>
             <a:picLocks noChangeAspect="1"/>
           </p:cNvPicPr>
@@ -12858,7 +12858,7 @@
       </p:sp>
       <p:pic>
         <p:nvPicPr>
-          <p:cNvPr id="5" name="Image 0" descr="C:\Users\0geda\OneDrive - University of Cape Town\Documents\PlatformIO\Projects\Tukzie-HPEC-HUD\.claude\worktrees\agent-ad83ea5807b9a7552\Presentation\source\assets\uct_logo.png">    </p:cNvPr>
+          <p:cNvPr id="5" name="Image 0" descr="C:\Users\0geda\OneDrive - University of Cape Town\Documents\PlatformIO\Projects\Tukzie-HPEC-HUD\Presentation\source\assets\uct_logo.png">    </p:cNvPr>
           <p:cNvPicPr>
             <a:picLocks noChangeAspect="1"/>
           </p:cNvPicPr>
@@ -13803,7 +13803,7 @@
       </p:sp>
       <p:pic>
         <p:nvPicPr>
-          <p:cNvPr id="5" name="Image 0" descr="C:\Users\0geda\OneDrive - University of Cape Town\Documents\PlatformIO\Projects\Tukzie-HPEC-HUD\.claude\worktrees\agent-ad83ea5807b9a7552\Presentation\source\assets\uct_logo.png">    </p:cNvPr>
+          <p:cNvPr id="5" name="Image 0" descr="C:\Users\0geda\OneDrive - University of Cape Town\Documents\PlatformIO\Projects\Tukzie-HPEC-HUD\Presentation\source\assets\uct_logo.png">    </p:cNvPr>
           <p:cNvPicPr>
             <a:picLocks noChangeAspect="1"/>
           </p:cNvPicPr>

</xml_diff>

<commit_message>
New title agreed 23 Oct: Embedded Telemetry, Road-Surface Characterisation and Camera-Based Hazard Detection for the TUKZIE Electric Tricycle (report, docs, deck, poster; word count 14,015)
</commit_message>
<xml_diff>
--- a/Presentation/SW7_Final_Presentation.pptx
+++ b/Presentation/SW7_Final_Presentation.pptx
@@ -2405,7 +2405,7 @@
               <a:buNone/>
             </a:pPr>
             <a:r>
-              <a:rPr lang="en-US" sz="3400" b="1" dirty="0">
+              <a:rPr lang="en-US" sz="3100" b="1" dirty="0">
                 <a:solidFill>
                   <a:srgbClr val="FFFFFF"/>
                 </a:solidFill>
@@ -2413,16 +2413,16 @@
                 <a:ea typeface="Calibri" pitchFamily="34" charset="-122"/>
                 <a:cs typeface="Calibri" pitchFamily="34" charset="-120"/>
               </a:rPr>
-              <a:t>Development of an Embedded HPEC Telemetry Unit</a:t>
-            </a:r>
-            <a:endParaRPr lang="en-US" sz="3400" dirty="0"/>
+              <a:t>Embedded Telemetry, Road-Surface Characterisation</a:t>
+            </a:r>
+            <a:endParaRPr lang="en-US" sz="3100" dirty="0"/>
           </a:p>
           <a:p>
             <a:pPr algn="ctr" indent="0" marL="0">
               <a:buNone/>
             </a:pPr>
             <a:r>
-              <a:rPr lang="en-US" sz="3400" b="1" dirty="0">
+              <a:rPr lang="en-US" sz="3100" b="1" dirty="0">
                 <a:solidFill>
                   <a:srgbClr val="FFFFFF"/>
                 </a:solidFill>
@@ -2430,9 +2430,26 @@
                 <a:ea typeface="Calibri" pitchFamily="34" charset="-122"/>
                 <a:cs typeface="Calibri" pitchFamily="34" charset="-120"/>
               </a:rPr>
-              <a:t>and Dashboard Integration for the TUKZIE Rev 0 Platform</a:t>
-            </a:r>
-            <a:endParaRPr lang="en-US" sz="3400" dirty="0"/>
+              <a:t>and Camera-Based Hazard Detection</a:t>
+            </a:r>
+            <a:endParaRPr lang="en-US" sz="3100" dirty="0"/>
+          </a:p>
+          <a:p>
+            <a:pPr algn="ctr" indent="0" marL="0">
+              <a:buNone/>
+            </a:pPr>
+            <a:r>
+              <a:rPr lang="en-US" sz="3100" b="1" dirty="0">
+                <a:solidFill>
+                  <a:srgbClr val="FFFFFF"/>
+                </a:solidFill>
+                <a:latin typeface="Calibri" pitchFamily="34" charset="0"/>
+                <a:ea typeface="Calibri" pitchFamily="34" charset="-122"/>
+                <a:cs typeface="Calibri" pitchFamily="34" charset="-120"/>
+              </a:rPr>
+              <a:t>for the TUKZIE Electric Tricycle</a:t>
+            </a:r>
+            <a:endParaRPr lang="en-US" sz="3100" dirty="0"/>
           </a:p>
         </p:txBody>
       </p:sp>

</xml_diff>

<commit_message>
Presentation: deck and poster updated with the 23 Oct stand runs, mounted calibration, phone GNSS, legibility measurement and the Monday road plan
</commit_message>
<xml_diff>
--- a/Presentation/SW7_Final_Presentation.pptx
+++ b/Presentation/SW7_Final_Presentation.pptx
@@ -875,7 +875,7 @@
           <a:p>
             <a:r>
               <a:rPr lang="en-US" dirty="0"/>
-              <a:t>Distance bands say how near an object is, not whether it is coming closer. For an object closing at constant speed, the inverse of its box width falls in a straight line to zero at contact. So time to contact is the width over its rate of growth, after Lee in 1976, and it needs no focal length or object size. I fit that line robustly over the last 0.6 seconds, and warn below 4 seconds, immediate below 2. In 40 synthetic tests it is within 2 percent, at 0.27 milliseconds a frame. It has not been tested on a real approach.</a:t>
+              <a:t>Distance bands say how near an object is, not whether it is coming closer. For an object closing at constant speed, the inverse of its box width falls in a straight line to zero at contact. So time to contact is the width over its rate of growth, after Lee in 1976, and it needs no focal length or object size. I fit that line robustly over the last 0.6 seconds, and warn below 4 seconds, immediate below 2. A one percent jitter in box width gives about plus or minus 0.3 seconds at 4 seconds. In 40 synthetic tests it is within 2 percent, at 0.27 milliseconds a frame. It has not been tested on a real approach.</a:t>
             </a:r>
             <a:endParaRPr lang="en-US" dirty="0"/>
           </a:p>
@@ -963,7 +963,7 @@
           <a:p>
             <a:r>
               <a:rPr lang="en-US" dirty="0"/>
-              <a:t>This is where RQ2 lands, on the dashboard the team already runs. The Surroundings page now has a Front and Rear switch, which moves the picture, alerts, distances and hazards together, each from that side's own unit. The rear view is mirrored like a reversing camera. The banner shows warnings from both sides, names the side, and puts an approaching object first. It shows only live data, never a simulated value. It is tested offscreen and live on the Pi 5; glance time on the vehicle is still open.</a:t>
+              <a:t>This is where RQ2 lands, on the dashboard the team already runs. A Front and Rear switch moves the picture, alerts and distances together, the rear mirrored; the banner names the side and puts an approaching object first; only live data is shown. Glance time needs a participant, but legibility does not, so I measured it. At 0.70 metres the speed digits subtend 84 arc minutes, far above the 20 ISO 15008 recommends; the alert banner subtends 9, and the labels a median of 9, against 16 acceptable. So the speed is legible at a glance; the warnings are not. Enlarging them comes before any glance study.</a:t>
             </a:r>
             <a:endParaRPr lang="en-US" dirty="0"/>
           </a:p>
@@ -1139,7 +1139,7 @@
           <a:p>
             <a:r>
               <a:rPr lang="en-US" dirty="0"/>
-              <a:t>On the nineteenth of October the whole system was mounted and the first road session run. A recorder on the Pi 5 ran for 108.6 minutes, about 16 of them driving, with no laptop on board. Both IMUs held 200 hertz with no drops and one short stall, but a third of the per-second records were lost on the USB link, now replaced by wires, so R1 is only partly met on the vehicle. The battery link held under load: up to 46.9 amps, the pack falling from 74.6 to 72.8 volts. The cameras raised 1,342 front and 741 rear alerts, not yet checked against video. But GNSS had no fix, as no antenna was fitted, and there were no raw samples or run markers, so RQ1 and RQ4 are not answered yet. A second, shorter session is planned.</a:t>
+              <a:t>On the nineteenth of October the whole system was mounted and the first road session run. A recorder on the Pi 5 ran for 108.6 minutes, about 16 of them driving, with no laptop on board. One IMU stall of about 2 seconds, not in the drop count, means R1 is not met on the vehicle, and 38 percent of the records were lost on USB, now replaced by wires. The battery link held at up to 46.9 amps. With no GNSS antenna and no raw samples, RQ1 and RQ4 stayed open. On the twenty-third, with the drive wheel raised, the rear vibration rose five to seven times, between about 40 and 70 hertz, and the front showed the same lines, so the powertrain reaches the front through the frame. Throttle settings were not recorded, so the lines are not yet assigned to motor orders. Monday's road run answers RQ1 and RQ4; the analysis is ready.</a:t>
             </a:r>
             <a:endParaRPr lang="en-US" dirty="0"/>
           </a:p>
@@ -1227,7 +1227,7 @@
           <a:p>
             <a:r>
               <a:rPr lang="en-US" dirty="0"/>
-              <a:t>To conclude. Every subsystem runs together, now on the vehicle: two IMUs at 200 hertz, fused; a database that lost nothing across an outage; detection in about 50 milliseconds at the front; an approaching-object warning; and both cameras on the existing dashboard. What remains is the second road session with raw data and GNSS for RQ1 and RQ4, the real approach test, glance time for RQ2, and a separate supply for the telemetry unit. Thank you, I'm happy to take questions.</a:t>
+              <a:t>To conclude. Every subsystem runs together, now on the vehicle: two nodes at 200 hertz with no counted drops; a database that lost nothing across an outage; detection in about 50 milliseconds at the front; an approaching-object warning; and both cameras on the existing dashboard. On the stands the powertrain showed at 40 to 70 hertz, at both ends; the dashboard's warnings are too small. What remains is Monday's road run for RQ1 and RQ4, larger warnings and then glance time for RQ2, the real approach test, and a separate supply for the telemetry unit. Thank you, I'm happy to take questions.</a:t>
             </a:r>
             <a:endParaRPr lang="en-US" dirty="0"/>
           </a:p>
@@ -1403,7 +1403,7 @@
           <a:p>
             <a:r>
               <a:rPr lang="en-US" dirty="0"/>
-              <a:t>Four research questions, and where each honestly stands. RQ1, how accurately and repeatably a low-cost unit characterises the ride: the instrument is verified, and on the first road session it held its rate, but repeatability is not measured yet. RQ2, alerts on the existing dashboard with the least distraction: this replaced the head-up display with my supervisor's agreement. It is built; glance time is not measured. RQ3, latency, loss and recovery: loss and recovery pass a ten-minute outage test; latency needs GNSS time. RQ4, road against powertrain vibration, needs the second road session.</a:t>
+              <a:t>Four research questions, and where each honestly stands. RQ1, how accurately and repeatably a low-cost unit characterises the ride: verified on the bench; road repeatability waits for Monday's run. RQ2, alerts on the existing dashboard with the least distraction: this replaced the head-up display with my supervisor's agreement. It is built and its legibility measured; glance time needs a participant. RQ3, latency, loss and recovery: loss and recovery pass a ten-minute outage test; latency needs GNSS time. RQ4, road against powertrain vibration: the stands found the powertrain's lines; their road share waits for the road run.</a:t>
             </a:r>
             <a:endParaRPr lang="en-US" dirty="0"/>
           </a:p>
@@ -1491,7 +1491,7 @@
           <a:p>
             <a:r>
               <a:rPr lang="en-US" dirty="0"/>
-              <a:t>Since the fifteenth of October the system has two sides, joined by one Ethernet cable. At the front, a Raspberry Pi 5 behind the dashboard runs its own camera, the detector, a time-of-flight board and the fusion, so a front alert never crosses the network. At the rear, beside the battery, the Pi 4 runs the rear camera and sensors and carries the telemetry unit: an ESP32-S3 with LTE and GNSS, two IMUs at 200 hertz and the battery link. Two findings drove this: the battery's Bluetooth did not reach the front, and the Pi 5 runs the detector more than twice as fast.</a:t>
+              <a:t>Since the fifteenth of October the system has two sides, joined by one Ethernet cable. At the front, a Raspberry Pi 5 behind the dashboard runs its own camera, the detector, a time-of-flight board and the fusion, so a front alert never crosses the network. At the rear, beside the battery, the Pi 4 runs the rear camera and sensors and carries the telemetry unit: an ESP32-S3 with LTE, GNSS, the battery link and one IMU at 200 hertz. A second node with its own IMU now sits at the front, so both ends are measured. Two findings drove this: the battery's Bluetooth did not reach the front, and the Pi 5 runs the detector more than twice as fast.</a:t>
             </a:r>
             <a:endParaRPr lang="en-US" dirty="0"/>
           </a:p>
@@ -1667,7 +1667,7 @@
           <a:p>
             <a:r>
               <a:rPr lang="en-US" dirty="0"/>
-              <a:t>Both IMUs run at 200 hertz with no dropped samples, counted, not assumed. Flash writes cause one gap of under 45 milliseconds a minute, and the queue holds the samples through it. A gravity factor per sensor brings both to 9.80 or 9.81, but only in that orientation, so it is redone once mounted. Fusion is an equal-weight mean; windows pair only if they end within half a window, and the disagreement is reported. In a 150 second session all 149 windows fused with under a millisecond of skew.</a:t>
+              <a:t>Both IMUs run at 200 hertz with no dropped samples, counted, not assumed. Flash writes cause one gap of under 45 milliseconds a minute, and the queue holds the samples through it. A gravity factor per sensor brings both to 9.80 or 9.81, but only in that orientation: with bench factors the parked vehicle read 10.04 and 10.34, so both were recalibrated mounted, not yet rechecked. In a 150 second session all 149 windows fused with under a millisecond of skew. One limit: the 94 hertz filter only partly suppresses aliasing, so a line at 40 to 70 hertz could be an image of one at 136 to 157. A speed sweep tells them apart: a motor line rises with speed, its image falls.</a:t>
             </a:r>
             <a:endParaRPr lang="en-US" dirty="0"/>
           </a:p>
@@ -1843,7 +1843,7 @@
           <a:p>
             <a:r>
               <a:rPr lang="en-US" dirty="0"/>
-              <a:t>The sync wire gives a median interval of 500.06 milliseconds over 121 edges, with under 0.7 of spread, so camera and IMU clocks line up. On a rooftop, GNSS was a median 2.7 metres from a phone. The outage test: I switched the radio off for ten minutes. The unit reconnected 5.2 seconds after it came back and cleared 60 records in about 40 seconds; the database holds 112 of 112. The public test broker does not queue, so the log read-back is the safety net, and latency needs GNSS time.</a:t>
+              <a:t>The sync wire gives a median interval of 500.06 milliseconds over 121 edges, with under 0.7 of spread, so camera and IMU clocks line up. On a rooftop, GNSS was a median 2.7 metres from a phone. On the vehicle it has not fixed yet, so a phone now streams its GNSS over its hotspot as the speed reference. The outage test: I switched the radio off for ten minutes. The unit reconnected 5.2 seconds after it came back and cleared 60 records in about 40 seconds; the database holds 112 of 112. The public test broker does not queue, so the log read-back is the safety net, and latency needs GNSS time.</a:t>
             </a:r>
             <a:endParaRPr lang="en-US" dirty="0"/>
           </a:p>
@@ -2817,7 +2817,7 @@
         </p:nvSpPr>
         <p:spPr>
           <a:xfrm>
-            <a:off x="1165860" y="2862072"/>
+            <a:off x="1165860" y="2724912"/>
             <a:ext cx="502920" cy="384048"/>
           </a:xfrm>
           <a:prstGeom prst="rect">
@@ -2842,7 +2842,7 @@
         </p:nvSpPr>
         <p:spPr>
           <a:xfrm>
-            <a:off x="2857500" y="2587752"/>
+            <a:off x="2857500" y="2450592"/>
             <a:ext cx="868680" cy="658368"/>
           </a:xfrm>
           <a:prstGeom prst="rect">
@@ -2867,7 +2867,7 @@
         </p:nvSpPr>
         <p:spPr>
           <a:xfrm>
-            <a:off x="4457700" y="2167128"/>
+            <a:off x="4457700" y="2029968"/>
             <a:ext cx="1417320" cy="1078992"/>
           </a:xfrm>
           <a:prstGeom prst="rect">
@@ -2892,7 +2892,7 @@
         </p:nvSpPr>
         <p:spPr>
           <a:xfrm>
-            <a:off x="685800" y="3319272"/>
+            <a:off x="685800" y="3182112"/>
             <a:ext cx="1463040" cy="274320"/>
           </a:xfrm>
           <a:prstGeom prst="rect">
@@ -2931,7 +2931,7 @@
         </p:nvSpPr>
         <p:spPr>
           <a:xfrm>
-            <a:off x="2560320" y="3319272"/>
+            <a:off x="2560320" y="3182112"/>
             <a:ext cx="1463040" cy="274320"/>
           </a:xfrm>
           <a:prstGeom prst="rect">
@@ -2970,7 +2970,7 @@
         </p:nvSpPr>
         <p:spPr>
           <a:xfrm>
-            <a:off x="4434840" y="3319272"/>
+            <a:off x="4434840" y="3182112"/>
             <a:ext cx="1463040" cy="274320"/>
           </a:xfrm>
           <a:prstGeom prst="rect">
@@ -3048,7 +3048,7 @@
         </p:nvSpPr>
         <p:spPr>
           <a:xfrm>
-            <a:off x="822960" y="3703320"/>
+            <a:off x="822960" y="3566160"/>
             <a:ext cx="5212080" cy="685800"/>
           </a:xfrm>
           <a:prstGeom prst="rect">
@@ -3087,8 +3087,8 @@
         </p:nvSpPr>
         <p:spPr>
           <a:xfrm>
-            <a:off x="822960" y="4480560"/>
-            <a:ext cx="5212080" cy="1600200"/>
+            <a:off x="822960" y="4297680"/>
+            <a:ext cx="5212080" cy="1828800"/>
           </a:xfrm>
           <a:prstGeom prst="rect">
             <a:avLst/>
@@ -3108,7 +3108,7 @@
               <a:buChar char="•"/>
             </a:pPr>
             <a:r>
-              <a:rPr lang="en-US" sz="1400" dirty="0">
+              <a:rPr lang="en-US" sz="1300" dirty="0">
                 <a:solidFill>
                   <a:srgbClr val="1B1F24"/>
                 </a:solidFill>
@@ -3118,7 +3118,7 @@
               </a:rPr>
               <a:t>1/w falls in a straight line to zero at contact; a Theil-Sen line is fitted over the last 0.6 s</a:t>
             </a:r>
-            <a:endParaRPr lang="en-US" sz="1400" dirty="0"/>
+            <a:endParaRPr lang="en-US" sz="1300" dirty="0"/>
           </a:p>
           <a:p>
             <a:pPr marL="228600" indent="-228600">
@@ -3129,7 +3129,7 @@
               <a:buChar char="•"/>
             </a:pPr>
             <a:r>
-              <a:rPr lang="en-US" sz="1400" dirty="0">
+              <a:rPr lang="en-US" sz="1300" dirty="0">
                 <a:solidFill>
                   <a:srgbClr val="1B1F24"/>
                 </a:solidFill>
@@ -3139,7 +3139,7 @@
               </a:rPr>
               <a:t>No focal length or object size needed (Lee 1976; Dagan et al. 2004)</a:t>
             </a:r>
-            <a:endParaRPr lang="en-US" sz="1400" dirty="0"/>
+            <a:endParaRPr lang="en-US" sz="1300" dirty="0"/>
           </a:p>
           <a:p>
             <a:pPr marL="228600" indent="-228600">
@@ -3150,7 +3150,7 @@
               <a:buChar char="•"/>
             </a:pPr>
             <a:r>
-              <a:rPr lang="en-US" sz="1400" dirty="0">
+              <a:rPr lang="en-US" sz="1300" dirty="0">
                 <a:solidFill>
                   <a:srgbClr val="1B1F24"/>
                 </a:solidFill>
@@ -3160,7 +3160,28 @@
               </a:rPr>
               <a:t>Used only with 5 frames over 0.25 s, 75 % of slopes agreeing, 5 % growth, box clear of the image edge</a:t>
             </a:r>
-            <a:endParaRPr lang="en-US" sz="1400" dirty="0"/>
+            <a:endParaRPr lang="en-US" sz="1300" dirty="0"/>
+          </a:p>
+          <a:p>
+            <a:pPr marL="228600" indent="-228600">
+              <a:spcAft>
+                <a:spcPts val="800"/>
+              </a:spcAft>
+              <a:buSzPct val="100000"/>
+              <a:buChar char="•"/>
+            </a:pPr>
+            <a:r>
+              <a:rPr lang="en-US" sz="1300" dirty="0">
+                <a:solidFill>
+                  <a:srgbClr val="1B1F24"/>
+                </a:solidFill>
+                <a:latin typeface="Calibri" pitchFamily="34" charset="0"/>
+                <a:ea typeface="Calibri" pitchFamily="34" charset="-122"/>
+                <a:cs typeface="Calibri" pitchFamily="34" charset="-120"/>
+              </a:rPr>
+              <a:t>Relative error ≈ ε (τ/T) √(12/n) for box jitter ε over n frames: 1 % jitter gives about ±0.3 s at 4 s</a:t>
+            </a:r>
+            <a:endParaRPr lang="en-US" sz="1300" dirty="0"/>
           </a:p>
         </p:txBody>
       </p:sp>
@@ -3608,7 +3629,7 @@
                 <a:ea typeface="Calibri" pitchFamily="34" charset="-122"/>
                 <a:cs typeface="Calibri" pitchFamily="34" charset="-120"/>
               </a:rPr>
-              <a:t>Both cameras on the existing dashboard</a:t>
+              <a:t>The existing dashboard: both cameras, and legibility</a:t>
             </a:r>
             <a:endParaRPr lang="en-US" sz="3200" dirty="0"/>
           </a:p>
@@ -3902,7 +3923,7 @@
                 <a:ea typeface="Calibri" pitchFamily="34" charset="-122"/>
                 <a:cs typeface="Calibri" pitchFamily="34" charset="-120"/>
               </a:rPr>
-              <a:t>Two cameras, one page (15 Oct)</a:t>
+              <a:t>Legibility at 0.70 m, measured without a participant (24 Oct)</a:t>
             </a:r>
             <a:endParaRPr lang="en-US" sz="1600" dirty="0"/>
           </a:p>
@@ -3917,7 +3938,7 @@
         <p:spPr>
           <a:xfrm>
             <a:off x="822960" y="4297680"/>
-            <a:ext cx="6217920" cy="1828800"/>
+            <a:ext cx="6217920" cy="1325880"/>
           </a:xfrm>
           <a:prstGeom prst="rect">
             <a:avLst/>
@@ -3945,7 +3966,7 @@
                 <a:ea typeface="Calibri" pitchFamily="34" charset="-122"/>
                 <a:cs typeface="Calibri" pitchFamily="34" charset="-120"/>
               </a:rPr>
-              <a:t>Front | Rear switch moves picture, alerts, distances and hazards together</a:t>
+              <a:t>Speed digits: 84 arc minutes (ISO 15008: 16 acceptable, 20 recommended)</a:t>
             </a:r>
             <a:endParaRPr lang="en-US" sz="1400" dirty="0"/>
           </a:p>
@@ -3966,7 +3987,7 @@
                 <a:ea typeface="Calibri" pitchFamily="34" charset="-122"/>
                 <a:cs typeface="Calibri" pitchFamily="34" charset="-120"/>
               </a:rPr>
-              <a:t>Rear view mirrored like a car's reversing camera</a:t>
+              <a:t>Alert banner capitals: 9 arc minutes; labels a median of 9</a:t>
             </a:r>
             <a:endParaRPr lang="en-US" sz="1400" dirty="0"/>
           </a:p>
@@ -3987,7 +4008,7 @@
                 <a:ea typeface="Calibri" pitchFamily="34" charset="-122"/>
                 <a:cs typeface="Calibri" pitchFamily="34" charset="-120"/>
               </a:rPr>
-              <a:t>Banner names the side; an approaching object comes first</a:t>
+              <a:t>Touch targets: median 10.9 mm; 5 of 26 at 17.5 mm</a:t>
             </a:r>
             <a:endParaRPr lang="en-US" sz="1400" dirty="0"/>
           </a:p>
@@ -4008,7 +4029,7 @@
                 <a:ea typeface="Calibri" pitchFamily="34" charset="-122"/>
                 <a:cs typeface="Calibri" pitchFamily="34" charset="-120"/>
               </a:rPr>
-              <a:t>Live data only: a lost side shows offline, never zero or the other side</a:t>
+              <a:t>First change: enlarge the banner to about 24 px capitals, then a glance study</a:t>
             </a:r>
             <a:endParaRPr lang="en-US" sz="1400" dirty="0"/>
           </a:p>
@@ -4016,7 +4037,46 @@
       </p:sp>
       <p:sp>
         <p:nvSpPr>
-          <p:cNvPr id="16" name="Shape 10"/>
+          <p:cNvPr id="16" name="Text 10"/>
+          <p:cNvSpPr txBox="1"/>
+          <p:nvPr/>
+        </p:nvSpPr>
+        <p:spPr>
+          <a:xfrm>
+            <a:off x="822960" y="5669280"/>
+            <a:ext cx="6217920" cy="365760"/>
+          </a:xfrm>
+          <a:prstGeom prst="rect">
+            <a:avLst/>
+          </a:prstGeom>
+          <a:noFill/>
+          <a:ln/>
+        </p:spPr>
+        <p:txBody>
+          <a:bodyPr wrap="square" lIns="0" tIns="0" rIns="0" bIns="0" rtlCol="0" anchor="ctr"/>
+          <a:lstStyle/>
+          <a:p>
+            <a:pPr indent="0" marL="0">
+              <a:buNone/>
+            </a:pPr>
+            <a:r>
+              <a:rPr lang="en-US" sz="1500" b="1" dirty="0">
+                <a:solidFill>
+                  <a:srgbClr val="D4700C"/>
+                </a:solidFill>
+                <a:latin typeface="Calibri" pitchFamily="34" charset="0"/>
+                <a:ea typeface="Calibri" pitchFamily="34" charset="-122"/>
+                <a:cs typeface="Calibri" pitchFamily="34" charset="-120"/>
+              </a:rPr>
+              <a:t>The speed is legible at a glance; the warnings are not.</a:t>
+            </a:r>
+            <a:endParaRPr lang="en-US" sz="1500" dirty="0"/>
+          </a:p>
+        </p:txBody>
+      </p:sp>
+      <p:sp>
+        <p:nvSpPr>
+          <p:cNvPr id="17" name="Shape 11"/>
           <p:cNvSpPr/>
           <p:nvPr/>
         </p:nvSpPr>
@@ -4043,7 +4103,7 @@
       </p:sp>
       <p:sp>
         <p:nvSpPr>
-          <p:cNvPr id="17" name="Text 11"/>
+          <p:cNvPr id="18" name="Text 12"/>
           <p:cNvSpPr txBox="1"/>
           <p:nvPr/>
         </p:nvSpPr>
@@ -4082,7 +4142,7 @@
       </p:sp>
       <p:pic>
         <p:nvPicPr>
-          <p:cNvPr id="18" name="Image 3" descr="C:\Users\0geda\OneDrive - University of Cape Town\Documents\PlatformIO\Projects\Tukzie-HPEC-HUD\Report\figures\ui\ui_pi5_live_dualcam.png">    </p:cNvPr>
+          <p:cNvPr id="19" name="Image 3" descr="C:\Users\0geda\OneDrive - University of Cape Town\Documents\PlatformIO\Projects\Tukzie-HPEC-HUD\Report\figures\ui\ui_pi5_live_dualcam.png">    </p:cNvPr>
           <p:cNvPicPr>
             <a:picLocks noChangeAspect="1"/>
           </p:cNvPicPr>
@@ -4106,7 +4166,7 @@
       </p:pic>
       <p:sp>
         <p:nvSpPr>
-          <p:cNvPr id="19" name="Text 12"/>
+          <p:cNvPr id="20" name="Text 13"/>
           <p:cNvSpPr txBox="1"/>
           <p:nvPr/>
         </p:nvSpPr>
@@ -4145,14 +4205,14 @@
       </p:sp>
       <p:sp>
         <p:nvSpPr>
-          <p:cNvPr id="20" name="Text 13"/>
+          <p:cNvPr id="21" name="Text 14"/>
           <p:cNvSpPr txBox="1"/>
           <p:nvPr/>
         </p:nvSpPr>
         <p:spPr>
           <a:xfrm>
             <a:off x="7909560" y="4539425"/>
-            <a:ext cx="3459175" cy="731520"/>
+            <a:ext cx="3459175" cy="1005840"/>
           </a:xfrm>
           <a:prstGeom prst="rect">
             <a:avLst/>
@@ -4180,7 +4240,7 @@
                 <a:ea typeface="Calibri" pitchFamily="34" charset="-122"/>
                 <a:cs typeface="Calibri" pitchFamily="34" charset="-120"/>
               </a:rPr>
-              <a:t>Tested offscreen with four fake servers</a:t>
+              <a:t>Front | Rear switch; rear view mirrored</a:t>
             </a:r>
             <a:endParaRPr lang="en-US" sz="1300" dirty="0"/>
           </a:p>
@@ -4201,22 +4261,43 @@
                 <a:ea typeface="Calibri" pitchFamily="34" charset="-122"/>
                 <a:cs typeface="Calibri" pitchFamily="34" charset="-120"/>
               </a:rPr>
-              <a:t>Paper theme, one tap colour, status in words</a:t>
+              <a:t>Banner names the side; approaching first</a:t>
             </a:r>
             <a:endParaRPr lang="en-US" sz="1300" dirty="0"/>
           </a:p>
-        </p:txBody>
-      </p:sp>
-      <p:sp>
-        <p:nvSpPr>
-          <p:cNvPr id="21" name="Text 14"/>
-          <p:cNvSpPr txBox="1"/>
-          <p:nvPr/>
-        </p:nvSpPr>
-        <p:spPr>
-          <a:xfrm>
-            <a:off x="7909560" y="5532120"/>
-            <a:ext cx="3459175" cy="548640"/>
+          <a:p>
+            <a:pPr marL="228600" indent="-228600">
+              <a:spcAft>
+                <a:spcPts val="800"/>
+              </a:spcAft>
+              <a:buSzPct val="100000"/>
+              <a:buChar char="•"/>
+            </a:pPr>
+            <a:r>
+              <a:rPr lang="en-US" sz="1300" dirty="0">
+                <a:solidFill>
+                  <a:srgbClr val="1B1F24"/>
+                </a:solidFill>
+                <a:latin typeface="Calibri" pitchFamily="34" charset="0"/>
+                <a:ea typeface="Calibri" pitchFamily="34" charset="-122"/>
+                <a:cs typeface="Calibri" pitchFamily="34" charset="-120"/>
+              </a:rPr>
+              <a:t>Live data only, never simulated</a:t>
+            </a:r>
+            <a:endParaRPr lang="en-US" sz="1300" dirty="0"/>
+          </a:p>
+        </p:txBody>
+      </p:sp>
+      <p:sp>
+        <p:nvSpPr>
+          <p:cNvPr id="22" name="Text 15"/>
+          <p:cNvSpPr txBox="1"/>
+          <p:nvPr/>
+        </p:nvSpPr>
+        <p:spPr>
+          <a:xfrm>
+            <a:off x="7909560" y="5623560"/>
+            <a:ext cx="3459175" cy="457200"/>
           </a:xfrm>
           <a:prstGeom prst="rect">
             <a:avLst/>
@@ -4254,7 +4335,7 @@
                 <a:ea typeface="Calibri" pitchFamily="34" charset="-122"/>
                 <a:cs typeface="Calibri" pitchFamily="34" charset="-120"/>
               </a:rPr>
-              <a:t>glance time on the vehicle, against NHTSA and ISO 15008.</a:t>
+              <a:t>glance time, which needs a participant.</a:t>
             </a:r>
             <a:endParaRPr lang="en-US" sz="1400" dirty="0"/>
           </a:p>
@@ -5275,7 +5356,7 @@
                 <a:ea typeface="Calibri" pitchFamily="34" charset="-122"/>
                 <a:cs typeface="Calibri" pitchFamily="34" charset="-120"/>
               </a:rPr>
-              <a:t>First road session, 19 October</a:t>
+              <a:t>On the vehicle: road session and stand runs</a:t>
             </a:r>
             <a:endParaRPr lang="en-US" sz="3200" dirty="0"/>
           </a:p>
@@ -5392,11 +5473,11 @@
         <p:spPr>
           <a:xfrm>
             <a:off x="548640" y="1280160"/>
-            <a:ext cx="3268980" cy="2011680"/>
+            <a:ext cx="2602154" cy="1508760"/>
           </a:xfrm>
           <a:prstGeom prst="roundRect">
             <a:avLst>
-              <a:gd name="adj" fmla="val 5455"/>
+              <a:gd name="adj" fmla="val 7273"/>
             </a:avLst>
           </a:prstGeom>
           <a:solidFill>
@@ -5418,8 +5499,8 @@
         </p:nvSpPr>
         <p:spPr>
           <a:xfrm>
-            <a:off x="822960" y="1417320"/>
-            <a:ext cx="2720340" cy="777240"/>
+            <a:off x="749808" y="1353312"/>
+            <a:ext cx="2199818" cy="566928"/>
           </a:xfrm>
           <a:prstGeom prst="rect">
             <a:avLst/>
@@ -5435,7 +5516,7 @@
               <a:buNone/>
             </a:pPr>
             <a:r>
-              <a:rPr lang="en-US" sz="3600" b="1" dirty="0">
+              <a:rPr lang="en-US" sz="2800" b="1" dirty="0">
                 <a:solidFill>
                   <a:srgbClr val="14305C"/>
                 </a:solidFill>
@@ -5445,7 +5526,7 @@
               </a:rPr>
               <a:t>108.6 min</a:t>
             </a:r>
-            <a:endParaRPr lang="en-US" sz="3600" dirty="0"/>
+            <a:endParaRPr lang="en-US" sz="2800" dirty="0"/>
           </a:p>
         </p:txBody>
       </p:sp>
@@ -5457,8 +5538,8 @@
         </p:nvSpPr>
         <p:spPr>
           <a:xfrm>
-            <a:off x="822960" y="2240280"/>
-            <a:ext cx="2720340" cy="960120"/>
+            <a:off x="749808" y="1938528"/>
+            <a:ext cx="2199818" cy="795528"/>
           </a:xfrm>
           <a:prstGeom prst="rect">
             <a:avLst/>
@@ -5474,7 +5555,7 @@
               <a:buNone/>
             </a:pPr>
             <a:r>
-              <a:rPr lang="en-US" sz="1400" dirty="0">
+              <a:rPr lang="en-US" sz="1200" dirty="0">
                 <a:solidFill>
                   <a:srgbClr val="1B1F24"/>
                 </a:solidFill>
@@ -5482,9 +5563,9 @@
                 <a:ea typeface="Calibri" pitchFamily="34" charset="-122"/>
                 <a:cs typeface="Calibri" pitchFamily="34" charset="-120"/>
               </a:rPr>
-              <a:t>recorded on the vehicle by the Pi 5, about 16 min of it driving</a:t>
-            </a:r>
-            <a:endParaRPr lang="en-US" sz="1400" dirty="0"/>
+              <a:t>recorded on 19 Oct, about 16 min driving; no GNSS fix (no antenna)</a:t>
+            </a:r>
+            <a:endParaRPr lang="en-US" sz="1200" dirty="0"/>
           </a:p>
         </p:txBody>
       </p:sp>
@@ -5496,12 +5577,12 @@
         </p:nvSpPr>
         <p:spPr>
           <a:xfrm>
-            <a:off x="4046220" y="1280160"/>
-            <a:ext cx="3268980" cy="2011680"/>
+            <a:off x="3379394" y="1280160"/>
+            <a:ext cx="2602154" cy="1508760"/>
           </a:xfrm>
           <a:prstGeom prst="roundRect">
             <a:avLst>
-              <a:gd name="adj" fmla="val 5455"/>
+              <a:gd name="adj" fmla="val 7273"/>
             </a:avLst>
           </a:prstGeom>
           <a:solidFill>
@@ -5523,8 +5604,8 @@
         </p:nvSpPr>
         <p:spPr>
           <a:xfrm>
-            <a:off x="4320540" y="1417320"/>
-            <a:ext cx="2720340" cy="777240"/>
+            <a:off x="3580562" y="1353312"/>
+            <a:ext cx="2199818" cy="566928"/>
           </a:xfrm>
           <a:prstGeom prst="rect">
             <a:avLst/>
@@ -5540,7 +5621,7 @@
               <a:buNone/>
             </a:pPr>
             <a:r>
-              <a:rPr lang="en-US" sz="3600" b="1" dirty="0">
+              <a:rPr lang="en-US" sz="2800" b="1" dirty="0">
                 <a:solidFill>
                   <a:srgbClr val="14305C"/>
                 </a:solidFill>
@@ -5550,7 +5631,7 @@
               </a:rPr>
               <a:t>200 Hz</a:t>
             </a:r>
-            <a:endParaRPr lang="en-US" sz="3600" dirty="0"/>
+            <a:endParaRPr lang="en-US" sz="2800" dirty="0"/>
           </a:p>
         </p:txBody>
       </p:sp>
@@ -5562,8 +5643,8 @@
         </p:nvSpPr>
         <p:spPr>
           <a:xfrm>
-            <a:off x="4320540" y="2240280"/>
-            <a:ext cx="2720340" cy="960120"/>
+            <a:off x="3580562" y="1938528"/>
+            <a:ext cx="2199818" cy="795528"/>
           </a:xfrm>
           <a:prstGeom prst="rect">
             <a:avLst/>
@@ -5579,7 +5660,7 @@
               <a:buNone/>
             </a:pPr>
             <a:r>
-              <a:rPr lang="en-US" sz="1400" dirty="0">
+              <a:rPr lang="en-US" sz="1200" dirty="0">
                 <a:solidFill>
                   <a:srgbClr val="1B1F24"/>
                 </a:solidFill>
@@ -5587,9 +5668,9 @@
                 <a:ea typeface="Calibri" pitchFamily="34" charset="-122"/>
                 <a:cs typeface="Calibri" pitchFamily="34" charset="-120"/>
               </a:rPr>
-              <a:t>both IMUs, no drops, one 2 s stall; 38 % of records lost on USB: R1 partly met</a:t>
-            </a:r>
-            <a:endParaRPr lang="en-US" sz="1400" dirty="0"/>
+              <a:t>no counted drops, but one 2 s stall: R1 not met on the vehicle; 38 % of records lost on USB</a:t>
+            </a:r>
+            <a:endParaRPr lang="en-US" sz="1200" dirty="0"/>
           </a:p>
         </p:txBody>
       </p:sp>
@@ -5601,12 +5682,12 @@
         </p:nvSpPr>
         <p:spPr>
           <a:xfrm>
-            <a:off x="548640" y="3520440"/>
-            <a:ext cx="3268980" cy="2011680"/>
+            <a:off x="6210148" y="1280160"/>
+            <a:ext cx="2602154" cy="1508760"/>
           </a:xfrm>
           <a:prstGeom prst="roundRect">
             <a:avLst>
-              <a:gd name="adj" fmla="val 5455"/>
+              <a:gd name="adj" fmla="val 7273"/>
             </a:avLst>
           </a:prstGeom>
           <a:solidFill>
@@ -5628,8 +5709,8 @@
         </p:nvSpPr>
         <p:spPr>
           <a:xfrm>
-            <a:off x="822960" y="3657600"/>
-            <a:ext cx="2720340" cy="777240"/>
+            <a:off x="6411316" y="1353312"/>
+            <a:ext cx="2199818" cy="566928"/>
           </a:xfrm>
           <a:prstGeom prst="rect">
             <a:avLst/>
@@ -5645,7 +5726,7 @@
               <a:buNone/>
             </a:pPr>
             <a:r>
-              <a:rPr lang="en-US" sz="3600" b="1" dirty="0">
+              <a:rPr lang="en-US" sz="2800" b="1" dirty="0">
                 <a:solidFill>
                   <a:srgbClr val="14305C"/>
                 </a:solidFill>
@@ -5655,7 +5736,7 @@
               </a:rPr>
               <a:t>46.9 A</a:t>
             </a:r>
-            <a:endParaRPr lang="en-US" sz="3600" dirty="0"/>
+            <a:endParaRPr lang="en-US" sz="2800" dirty="0"/>
           </a:p>
         </p:txBody>
       </p:sp>
@@ -5667,8 +5748,8 @@
         </p:nvSpPr>
         <p:spPr>
           <a:xfrm>
-            <a:off x="822960" y="4480560"/>
-            <a:ext cx="2720340" cy="960120"/>
+            <a:off x="6411316" y="1938528"/>
+            <a:ext cx="2199818" cy="795528"/>
           </a:xfrm>
           <a:prstGeom prst="rect">
             <a:avLst/>
@@ -5684,7 +5765,7 @@
               <a:buNone/>
             </a:pPr>
             <a:r>
-              <a:rPr lang="en-US" sz="1400" dirty="0">
+              <a:rPr lang="en-US" sz="1200" dirty="0">
                 <a:solidFill>
                   <a:srgbClr val="1B1F24"/>
                 </a:solidFill>
@@ -5692,9 +5773,9 @@
                 <a:ea typeface="Calibri" pitchFamily="34" charset="-122"/>
                 <a:cs typeface="Calibri" pitchFamily="34" charset="-120"/>
               </a:rPr>
-              <a:t>peak battery current; 74.6 to 72.8 V, 60 to 58 %: R5 partly met (no meter check)</a:t>
-            </a:r>
-            <a:endParaRPr lang="en-US" sz="1400" dirty="0"/>
+              <a:t>peak battery current; 74.6 to 72.8 V: R5 partly met (no meter check)</a:t>
+            </a:r>
+            <a:endParaRPr lang="en-US" sz="1200" dirty="0"/>
           </a:p>
         </p:txBody>
       </p:sp>
@@ -5706,12 +5787,12 @@
         </p:nvSpPr>
         <p:spPr>
           <a:xfrm>
-            <a:off x="4046220" y="3520440"/>
-            <a:ext cx="3268980" cy="2011680"/>
+            <a:off x="9040901" y="1280160"/>
+            <a:ext cx="2602154" cy="1508760"/>
           </a:xfrm>
           <a:prstGeom prst="roundRect">
             <a:avLst>
-              <a:gd name="adj" fmla="val 5455"/>
+              <a:gd name="adj" fmla="val 7273"/>
             </a:avLst>
           </a:prstGeom>
           <a:solidFill>
@@ -5733,8 +5814,8 @@
         </p:nvSpPr>
         <p:spPr>
           <a:xfrm>
-            <a:off x="4320540" y="3657600"/>
-            <a:ext cx="2720340" cy="777240"/>
+            <a:off x="9242069" y="1353312"/>
+            <a:ext cx="2199818" cy="566928"/>
           </a:xfrm>
           <a:prstGeom prst="rect">
             <a:avLst/>
@@ -5750,7 +5831,7 @@
               <a:buNone/>
             </a:pPr>
             <a:r>
-              <a:rPr lang="en-US" sz="3600" b="1" dirty="0">
+              <a:rPr lang="en-US" sz="2800" b="1" dirty="0">
                 <a:solidFill>
                   <a:srgbClr val="14305C"/>
                 </a:solidFill>
@@ -5760,7 +5841,7 @@
               </a:rPr>
               <a:t>1,342 / 741</a:t>
             </a:r>
-            <a:endParaRPr lang="en-US" sz="3600" dirty="0"/>
+            <a:endParaRPr lang="en-US" sz="2800" dirty="0"/>
           </a:p>
         </p:txBody>
       </p:sp>
@@ -5772,8 +5853,8 @@
         </p:nvSpPr>
         <p:spPr>
           <a:xfrm>
-            <a:off x="4320540" y="4480560"/>
-            <a:ext cx="2720340" cy="960120"/>
+            <a:off x="9242069" y="1938528"/>
+            <a:ext cx="2199818" cy="795528"/>
           </a:xfrm>
           <a:prstGeom prst="rect">
             <a:avLst/>
@@ -5789,7 +5870,7 @@
               <a:buNone/>
             </a:pPr>
             <a:r>
-              <a:rPr lang="en-US" sz="1400" dirty="0">
+              <a:rPr lang="en-US" sz="1200" dirty="0">
                 <a:solidFill>
                   <a:srgbClr val="1B1F24"/>
                 </a:solidFill>
@@ -5799,20 +5880,44 @@
               </a:rPr>
               <a:t>front and rear camera alerts, not yet checked against video</a:t>
             </a:r>
-            <a:endParaRPr lang="en-US" sz="1400" dirty="0"/>
-          </a:p>
-        </p:txBody>
-      </p:sp>
-      <p:sp>
-        <p:nvSpPr>
-          <p:cNvPr id="21" name="Text 17"/>
-          <p:cNvSpPr txBox="1"/>
-          <p:nvPr/>
-        </p:nvSpPr>
-        <p:spPr>
-          <a:xfrm>
-            <a:off x="548640" y="5623560"/>
-            <a:ext cx="6766560" cy="548640"/>
+            <a:endParaRPr lang="en-US" sz="1200" dirty="0"/>
+          </a:p>
+        </p:txBody>
+      </p:sp>
+      <p:pic>
+        <p:nvPicPr>
+          <p:cNvPr id="21" name="Image 1" descr="C:\Users\0geda\OneDrive - University of Cape Town\Documents\PlatformIO\Projects\Tukzie-HPEC-HUD\Report\figures\results\stand_spectra_1023.png">    </p:cNvPr>
+          <p:cNvPicPr>
+            <a:picLocks noChangeAspect="1"/>
+          </p:cNvPicPr>
+          <p:nvPr/>
+        </p:nvPicPr>
+        <p:blipFill>
+          <a:blip r:embed="rId2"/>
+          <a:stretch>
+            <a:fillRect/>
+          </a:stretch>
+        </p:blipFill>
+        <p:spPr>
+          <a:xfrm>
+            <a:off x="548640" y="3017520"/>
+            <a:ext cx="6766560" cy="2435962"/>
+          </a:xfrm>
+          <a:prstGeom prst="rect">
+            <a:avLst/>
+          </a:prstGeom>
+        </p:spPr>
+      </p:pic>
+      <p:sp>
+        <p:nvSpPr>
+          <p:cNvPr id="22" name="Text 17"/>
+          <p:cNvSpPr txBox="1"/>
+          <p:nvPr/>
+        </p:nvSpPr>
+        <p:spPr>
+          <a:xfrm>
+            <a:off x="548640" y="5499202"/>
+            <a:ext cx="6766560" cy="764438"/>
           </a:xfrm>
           <a:prstGeom prst="rect">
             <a:avLst/>
@@ -5836,7 +5941,7 @@
                 <a:ea typeface="Calibri" pitchFamily="34" charset="-122"/>
                 <a:cs typeface="Calibri" pitchFamily="34" charset="-120"/>
               </a:rPr>
-              <a:t>Parked and driving separate clearly: one-second vibration median 0.03 parked; while driving median 1.39, 95th percentile 3.2, maximum 5.09.</a:t>
+              <a:t>Stand runs, 23 Oct, drive wheel raised (3.2 and 4.5 A): rear vibration 5 to 7 times rest, energy 40 to 70 Hz; the same lines at the front (42.75, 49.0, 64.0 Hz). Throttle settings not recorded.</a:t>
             </a:r>
             <a:endParaRPr lang="en-US" sz="1200" dirty="0"/>
           </a:p>
@@ -5844,18 +5949,18 @@
       </p:sp>
       <p:sp>
         <p:nvSpPr>
-          <p:cNvPr id="22" name="Shape 18"/>
+          <p:cNvPr id="23" name="Shape 18"/>
           <p:cNvSpPr/>
           <p:nvPr/>
         </p:nvSpPr>
         <p:spPr>
           <a:xfrm>
-            <a:off x="7635240" y="1280160"/>
-            <a:ext cx="4007815" cy="4892040"/>
+            <a:off x="7635240" y="3017520"/>
+            <a:ext cx="4007815" cy="3154680"/>
           </a:xfrm>
           <a:prstGeom prst="roundRect">
             <a:avLst>
-              <a:gd name="adj" fmla="val 2738"/>
+              <a:gd name="adj" fmla="val 3478"/>
             </a:avLst>
           </a:prstGeom>
           <a:solidFill>
@@ -5871,14 +5976,14 @@
       </p:sp>
       <p:sp>
         <p:nvSpPr>
-          <p:cNvPr id="23" name="Text 19"/>
-          <p:cNvSpPr txBox="1"/>
-          <p:nvPr/>
-        </p:nvSpPr>
-        <p:spPr>
-          <a:xfrm>
-            <a:off x="7909560" y="1417320"/>
-            <a:ext cx="3459175" cy="365760"/>
+          <p:cNvPr id="24" name="Text 19"/>
+          <p:cNvSpPr txBox="1"/>
+          <p:nvPr/>
+        </p:nvSpPr>
+        <p:spPr>
+          <a:xfrm>
+            <a:off x="7863840" y="3127248"/>
+            <a:ext cx="3550615" cy="365760"/>
           </a:xfrm>
           <a:prstGeom prst="rect">
             <a:avLst/>
@@ -5894,7 +5999,7 @@
               <a:buNone/>
             </a:pPr>
             <a:r>
-              <a:rPr lang="en-US" sz="1800" b="1" dirty="0">
+              <a:rPr lang="en-US" sz="1600" b="1" dirty="0">
                 <a:solidFill>
                   <a:srgbClr val="D4700C"/>
                 </a:solidFill>
@@ -5902,22 +6007,22 @@
                 <a:ea typeface="Calibri" pitchFamily="34" charset="-122"/>
                 <a:cs typeface="Calibri" pitchFamily="34" charset="-120"/>
               </a:rPr>
-              <a:t>Not captured, so still open</a:t>
-            </a:r>
-            <a:endParaRPr lang="en-US" sz="1800" dirty="0"/>
-          </a:p>
-        </p:txBody>
-      </p:sp>
-      <p:sp>
-        <p:nvSpPr>
-          <p:cNvPr id="24" name="Text 20"/>
-          <p:cNvSpPr txBox="1"/>
-          <p:nvPr/>
-        </p:nvSpPr>
-        <p:spPr>
-          <a:xfrm>
-            <a:off x="7909560" y="1920240"/>
-            <a:ext cx="3459175" cy="4114800"/>
+              <a:t>Pending: road run, Monday 26 Oct</a:t>
+            </a:r>
+            <a:endParaRPr lang="en-US" sz="1600" dirty="0"/>
+          </a:p>
+        </p:txBody>
+      </p:sp>
+      <p:sp>
+        <p:nvSpPr>
+          <p:cNvPr id="25" name="Text 20"/>
+          <p:cNvSpPr txBox="1"/>
+          <p:nvPr/>
+        </p:nvSpPr>
+        <p:spPr>
+          <a:xfrm>
+            <a:off x="7863840" y="3547872"/>
+            <a:ext cx="3550615" cy="2560320"/>
           </a:xfrm>
           <a:prstGeom prst="rect">
             <a:avLst/>
@@ -5937,7 +6042,7 @@
               <a:buChar char="•"/>
             </a:pPr>
             <a:r>
-              <a:rPr lang="en-US" sz="1500" dirty="0">
+              <a:rPr lang="en-US" sz="1300" dirty="0">
                 <a:solidFill>
                   <a:srgbClr val="1B1F24"/>
                 </a:solidFill>
@@ -5945,9 +6050,9 @@
                 <a:ea typeface="Calibri" pitchFamily="34" charset="-122"/>
                 <a:cs typeface="Calibri" pitchFamily="34" charset="-120"/>
               </a:rPr>
-              <a:t>No GNSS fix in any record (no antenna fitted): R4 untested on the vehicle, and no speed</a:t>
-            </a:r>
-            <a:endParaRPr lang="en-US" sz="1500" dirty="0"/>
+              <a:t>RQ1: repeatability over passes at 10, 15 and 20 km/h</a:t>
+            </a:r>
+            <a:endParaRPr lang="en-US" sz="1300" dirty="0"/>
           </a:p>
           <a:p>
             <a:pPr marL="228600" indent="-228600">
@@ -5958,7 +6063,7 @@
               <a:buChar char="•"/>
             </a:pPr>
             <a:r>
-              <a:rPr lang="en-US" sz="1500" dirty="0">
+              <a:rPr lang="en-US" sz="1300" dirty="0">
                 <a:solidFill>
                   <a:srgbClr val="1B1F24"/>
                 </a:solidFill>
@@ -5966,9 +6071,9 @@
                 <a:ea typeface="Calibri" pitchFamily="34" charset="-122"/>
                 <a:cs typeface="Calibri" pitchFamily="34" charset="-120"/>
               </a:rPr>
-              <a:t>No raw 200 Hz samples (v0.7.4) and no run markers: RQ1 and RQ4 not answered yet</a:t>
-            </a:r>
-            <a:endParaRPr lang="en-US" sz="1500" dirty="0"/>
+              <a:t>RQ4: the stand lines' share of the road spectrum, powered and coasting</a:t>
+            </a:r>
+            <a:endParaRPr lang="en-US" sz="1300" dirty="0"/>
           </a:p>
           <a:p>
             <a:pPr marL="228600" indent="-228600">
@@ -5979,7 +6084,7 @@
               <a:buChar char="•"/>
             </a:pPr>
             <a:r>
-              <a:rPr lang="en-US" sz="1500" dirty="0">
+              <a:rPr lang="en-US" sz="1300" dirty="0">
                 <a:solidFill>
                   <a:srgbClr val="1B1F24"/>
                 </a:solidFill>
@@ -5987,9 +6092,9 @@
                 <a:ea typeface="Calibri" pitchFamily="34" charset="-122"/>
                 <a:cs typeface="Calibri" pitchFamily="34" charset="-120"/>
               </a:rPr>
-              <a:t>LTE upload down: no latency</a:t>
-            </a:r>
-            <a:endParaRPr lang="en-US" sz="1500" dirty="0"/>
+              <a:t>Speed index σ²/v: constant with speed if the ISO 8608 road model holds</a:t>
+            </a:r>
+            <a:endParaRPr lang="en-US" sz="1300" dirty="0"/>
           </a:p>
           <a:p>
             <a:pPr marL="228600" indent="-228600">
@@ -6000,7 +6105,7 @@
               <a:buChar char="•"/>
             </a:pPr>
             <a:r>
-              <a:rPr lang="en-US" sz="1500" dirty="0">
+              <a:rPr lang="en-US" sz="1300" dirty="0">
                 <a:solidFill>
                   <a:srgbClr val="1B1F24"/>
                 </a:solidFill>
@@ -6008,9 +6113,9 @@
                 <a:ea typeface="Calibri" pitchFamily="34" charset="-122"/>
                 <a:cs typeface="Calibri" pitchFamily="34" charset="-120"/>
               </a:rPr>
-              <a:t>Driving found afterwards from battery current and vibration; no gear or speed signal</a:t>
-            </a:r>
-            <a:endParaRPr lang="en-US" sz="1500" dirty="0"/>
+              <a:t>Speed from the front-to-rear delay: timing budget 5.3 ms, 1.8 % of a 0.3 s delay</a:t>
+            </a:r>
+            <a:endParaRPr lang="en-US" sz="1300" dirty="0"/>
           </a:p>
           <a:p>
             <a:pPr marL="228600" indent="-228600">
@@ -6021,7 +6126,7 @@
               <a:buChar char="•"/>
             </a:pPr>
             <a:r>
-              <a:rPr lang="en-US" sz="1500" dirty="0">
+              <a:rPr lang="en-US" sz="1300" dirty="0">
                 <a:solidFill>
                   <a:srgbClr val="1B1F24"/>
                 </a:solidFill>
@@ -6029,9 +6134,9 @@
                 <a:ea typeface="Calibri" pitchFamily="34" charset="-122"/>
                 <a:cs typeface="Calibri" pitchFamily="34" charset="-120"/>
               </a:rPr>
-              <a:t>Next: a second, shorter session with the raw stream (v0.7.5), a working GNSS antenna, timed runs and the powertrain baseline on stands</a:t>
-            </a:r>
-            <a:endParaRPr lang="en-US" sz="1500" dirty="0"/>
+              <a:t>Phone GNSS speed against video</a:t>
+            </a:r>
+            <a:endParaRPr lang="en-US" sz="1300" dirty="0"/>
           </a:p>
         </p:txBody>
       </p:sp>
@@ -6375,7 +6480,7 @@
                 <a:ea typeface="Calibri" pitchFamily="34" charset="-122"/>
                 <a:cs typeface="Calibri" pitchFamily="34" charset="-120"/>
               </a:rPr>
-              <a:t>Two IMUs at 200 Hz, fused; held on the vehicle (R1)</a:t>
+              <a:t>200 Hz, no drops on both nodes on the bench (R1); one 2 s stall on the road</a:t>
             </a:r>
             <a:endParaRPr lang="en-US" sz="1600" dirty="0"/>
           </a:p>
@@ -6459,7 +6564,7 @@
                 <a:ea typeface="Calibri" pitchFamily="34" charset="-122"/>
                 <a:cs typeface="Calibri" pitchFamily="34" charset="-120"/>
               </a:rPr>
-              <a:t>Both cameras on the existing dashboard, live data only</a:t>
+              <a:t>Stands: powertrain at 40 to 70 Hz, rear and front</a:t>
             </a:r>
             <a:endParaRPr lang="en-US" sz="1600" dirty="0"/>
           </a:p>
@@ -6480,7 +6585,7 @@
                 <a:ea typeface="Calibri" pitchFamily="34" charset="-122"/>
                 <a:cs typeface="Calibri" pitchFamily="34" charset="-120"/>
               </a:rPr>
-              <a:t>Battery under load on the vehicle (R5); seven faults fixed</a:t>
+              <a:t>Dashboard: speed legible, warnings too small (ISO 15008)</a:t>
             </a:r>
             <a:endParaRPr lang="en-US" sz="1600" dirty="0"/>
           </a:p>
@@ -6589,7 +6694,7 @@
                 <a:ea typeface="Calibri" pitchFamily="34" charset="-122"/>
                 <a:cs typeface="Calibri" pitchFamily="34" charset="-120"/>
               </a:rPr>
-              <a:t>Second road session: raw samples, GNSS, timed runs (RQ1, RQ4)</a:t>
+              <a:t>Road run, 26 Oct: repeatability (RQ1), road share (RQ4)</a:t>
             </a:r>
             <a:endParaRPr lang="en-US" sz="1600" dirty="0"/>
           </a:p>
@@ -6610,7 +6715,7 @@
                 <a:ea typeface="Calibri" pitchFamily="34" charset="-122"/>
                 <a:cs typeface="Calibri" pitchFamily="34" charset="-120"/>
               </a:rPr>
-              <a:t>Real approach test (C11), fusion and focal calibration (C9)</a:t>
+              <a:t>Enlarge the warnings, then glance time (RQ2)</a:t>
             </a:r>
             <a:endParaRPr lang="en-US" sz="1600" dirty="0"/>
           </a:p>
@@ -6631,7 +6736,7 @@
                 <a:ea typeface="Calibri" pitchFamily="34" charset="-122"/>
                 <a:cs typeface="Calibri" pitchFamily="34" charset="-120"/>
               </a:rPr>
-              <a:t>Glance time on the vehicle (RQ2); latency with GNSS time</a:t>
+              <a:t>Real approach test (C11); latency with GNSS time</a:t>
             </a:r>
             <a:endParaRPr lang="en-US" sz="1600" dirty="0"/>
           </a:p>
@@ -6652,7 +6757,7 @@
                 <a:ea typeface="Calibri" pitchFamily="34" charset="-122"/>
                 <a:cs typeface="Calibri" pitchFamily="34" charset="-120"/>
               </a:rPr>
-              <a:t>Own supply for the telemetry unit; measure each unit's power</a:t>
+              <a:t>Own supply for the telemetry unit (Pi 4 still under-voltage, 23 Oct)</a:t>
             </a:r>
             <a:endParaRPr lang="en-US" sz="1600" dirty="0"/>
           </a:p>
@@ -7655,13 +7760,13 @@
             </a:avLst>
           </a:prstGeom>
           <a:solidFill>
-            <a:srgbClr val="14305C"/>
+            <a:srgbClr val="FFFFFF"/>
           </a:solidFill>
           <a:ln w="19050">
             <a:solidFill>
-              <a:srgbClr val="14305C"/>
+              <a:srgbClr val="D4700C"/>
             </a:solidFill>
-            <a:prstDash val="solid"/>
+            <a:prstDash val="dash"/>
           </a:ln>
         </p:spPr>
       </p:sp>
@@ -7692,13 +7797,13 @@
             <a:r>
               <a:rPr lang="en-US" sz="1500" b="1" dirty="0">
                 <a:solidFill>
-                  <a:srgbClr val="FFFFFF"/>
-                </a:solidFill>
-                <a:latin typeface="Calibri" pitchFamily="34" charset="0"/>
-                <a:ea typeface="Calibri" pitchFamily="34" charset="-122"/>
-                <a:cs typeface="Calibri" pitchFamily="34" charset="-120"/>
-              </a:rPr>
-              <a:t>Rate held on road</a:t>
+                  <a:srgbClr val="D4700C"/>
+                </a:solidFill>
+                <a:latin typeface="Calibri" pitchFamily="34" charset="0"/>
+                <a:ea typeface="Calibri" pitchFamily="34" charset="-122"/>
+                <a:cs typeface="Calibri" pitchFamily="34" charset="-120"/>
+              </a:rPr>
+              <a:t>Road run pending</a:t>
             </a:r>
             <a:endParaRPr lang="en-US" sz="1500" dirty="0"/>
           </a:p>
@@ -7826,13 +7931,13 @@
             </a:avLst>
           </a:prstGeom>
           <a:solidFill>
-            <a:srgbClr val="FFFFFF"/>
+            <a:srgbClr val="14305C"/>
           </a:solidFill>
           <a:ln w="19050">
             <a:solidFill>
-              <a:srgbClr val="D4700C"/>
+              <a:srgbClr val="14305C"/>
             </a:solidFill>
-            <a:prstDash val="dash"/>
+            <a:prstDash val="solid"/>
           </a:ln>
         </p:spPr>
       </p:sp>
@@ -7863,13 +7968,13 @@
             <a:r>
               <a:rPr lang="en-US" sz="1500" b="1" dirty="0">
                 <a:solidFill>
-                  <a:srgbClr val="D4700C"/>
-                </a:solidFill>
-                <a:latin typeface="Calibri" pitchFamily="34" charset="0"/>
-                <a:ea typeface="Calibri" pitchFamily="34" charset="-122"/>
-                <a:cs typeface="Calibri" pitchFamily="34" charset="-120"/>
-              </a:rPr>
-              <a:t>Glance untested</a:t>
+                  <a:srgbClr val="FFFFFF"/>
+                </a:solidFill>
+                <a:latin typeface="Calibri" pitchFamily="34" charset="0"/>
+                <a:ea typeface="Calibri" pitchFamily="34" charset="-122"/>
+                <a:cs typeface="Calibri" pitchFamily="34" charset="-120"/>
+              </a:rPr>
+              <a:t>Legibility measured</a:t>
             </a:r>
             <a:endParaRPr lang="en-US" sz="1500" dirty="0"/>
           </a:p>
@@ -8168,13 +8273,13 @@
             </a:avLst>
           </a:prstGeom>
           <a:solidFill>
-            <a:srgbClr val="FFFFFF"/>
+            <a:srgbClr val="14305C"/>
           </a:solidFill>
           <a:ln w="19050">
             <a:solidFill>
-              <a:srgbClr val="D4700C"/>
+              <a:srgbClr val="14305C"/>
             </a:solidFill>
-            <a:prstDash val="dash"/>
+            <a:prstDash val="solid"/>
           </a:ln>
         </p:spPr>
       </p:sp>
@@ -8205,13 +8310,13 @@
             <a:r>
               <a:rPr lang="en-US" sz="1500" b="1" dirty="0">
                 <a:solidFill>
-                  <a:srgbClr val="D4700C"/>
-                </a:solidFill>
-                <a:latin typeface="Calibri" pitchFamily="34" charset="0"/>
-                <a:ea typeface="Calibri" pitchFamily="34" charset="-122"/>
-                <a:cs typeface="Calibri" pitchFamily="34" charset="-120"/>
-              </a:rPr>
-              <a:t>Needs session 2</a:t>
+                  <a:srgbClr val="FFFFFF"/>
+                </a:solidFill>
+                <a:latin typeface="Calibri" pitchFamily="34" charset="0"/>
+                <a:ea typeface="Calibri" pitchFamily="34" charset="-122"/>
+                <a:cs typeface="Calibri" pitchFamily="34" charset="-120"/>
+              </a:rPr>
+              <a:t>Stand lines found</a:t>
             </a:r>
             <a:endParaRPr lang="en-US" sz="1500" dirty="0"/>
           </a:p>
@@ -8574,7 +8679,7 @@
                 <a:ea typeface="Calibri" pitchFamily="34" charset="-122"/>
                 <a:cs typeface="Calibri" pitchFamily="34" charset="-120"/>
               </a:rPr>
-              <a:t>Front camera and object detector</a:t>
+              <a:t>Front camera, detector, time-of-flight board</a:t>
             </a:r>
             <a:endParaRPr lang="en-US" sz="1600" dirty="0"/>
           </a:p>
@@ -8595,7 +8700,7 @@
                 <a:ea typeface="Calibri" pitchFamily="34" charset="-122"/>
                 <a:cs typeface="Calibri" pitchFamily="34" charset="-120"/>
               </a:rPr>
-              <a:t>Time-of-flight board (left, ahead, right) and camera fusion</a:t>
+              <a:t>Front node: ESP32-S3 with one IMU at 200 Hz</a:t>
             </a:r>
             <a:endParaRPr lang="en-US" sz="1600" dirty="0"/>
           </a:p>
@@ -8616,7 +8721,7 @@
                 <a:ea typeface="Calibri" pitchFamily="34" charset="-122"/>
                 <a:cs typeface="Calibri" pitchFamily="34" charset="-120"/>
               </a:rPr>
-              <a:t>Dashboard on the 10.1 in touchscreen</a:t>
+              <a:t>Dashboard on the 10.1 in touchscreen; phone GNSS for speed</a:t>
             </a:r>
             <a:endParaRPr lang="en-US" sz="1600" dirty="0"/>
           </a:p>
@@ -8637,7 +8742,7 @@
                 <a:ea typeface="Calibri" pitchFamily="34" charset="-122"/>
                 <a:cs typeface="Calibri" pitchFamily="34" charset="-120"/>
               </a:rPr>
-              <a:t>Road recorder: all four sources at 2 Hz</a:t>
+              <a:t>Road recorder for all sources</a:t>
             </a:r>
             <a:endParaRPr lang="en-US" sz="1600" dirty="0"/>
           </a:p>
@@ -8784,7 +8889,7 @@
                 <a:ea typeface="Calibri" pitchFamily="34" charset="-122"/>
                 <a:cs typeface="Calibri" pitchFamily="34" charset="-120"/>
               </a:rPr>
-              <a:t>Telemetry unit on USB: ESP32-S3 with LTE, GNSS, local log</a:t>
+              <a:t>Rear node: ESP32-S3 with one IMU at 200 Hz, wired UART</a:t>
             </a:r>
             <a:endParaRPr lang="en-US" sz="1600" dirty="0"/>
           </a:p>
@@ -8805,7 +8910,7 @@
                 <a:ea typeface="Calibri" pitchFamily="34" charset="-122"/>
                 <a:cs typeface="Calibri" pitchFamily="34" charset="-120"/>
               </a:rPr>
-              <a:t>Two IMUs at 200 Hz; battery over Bluetooth; Hall counter</a:t>
+              <a:t>LTE, GNSS, local log; battery over Bluetooth</a:t>
             </a:r>
             <a:endParaRPr lang="en-US" sz="1600" dirty="0"/>
           </a:p>
@@ -11468,7 +11573,7 @@
                 <a:ea typeface="Calibri" pitchFamily="34" charset="-122"/>
                 <a:cs typeface="Calibri" pitchFamily="34" charset="-120"/>
               </a:rPr>
-              <a:t>Fusion rules and limits</a:t>
+              <a:t>Calibration and limits</a:t>
             </a:r>
             <a:endParaRPr lang="en-US" sz="1800" dirty="0"/>
           </a:p>
@@ -11511,7 +11616,7 @@
                 <a:ea typeface="Calibri" pitchFamily="34" charset="-122"/>
                 <a:cs typeface="Calibri" pitchFamily="34" charset="-120"/>
               </a:rPr>
-              <a:t>Equal-weight mean (equal noise)</a:t>
+              <a:t>Bench factors on the parked vehicle: 10.04 and 10.34 m/s²</a:t>
             </a:r>
             <a:endParaRPr lang="en-US" sz="1300" dirty="0"/>
           </a:p>
@@ -11532,7 +11637,7 @@
                 <a:ea typeface="Calibri" pitchFamily="34" charset="-122"/>
                 <a:cs typeface="Calibri" pitchFamily="34" charset="-120"/>
               </a:rPr>
-              <a:t>Paired if windows end within 500 ms</a:t>
+              <a:t>Mounted (23 Oct): front 0.9919, rear 1.0094; not yet rechecked</a:t>
             </a:r>
             <a:endParaRPr lang="en-US" sz="1300" dirty="0"/>
           </a:p>
@@ -11553,7 +11658,7 @@
                 <a:ea typeface="Calibri" pitchFamily="34" charset="-122"/>
                 <a:cs typeface="Calibri" pitchFamily="34" charset="-120"/>
               </a:rPr>
-              <a:t>Disagreement reported; 3 s fallback</a:t>
+              <a:t>Flash gaps 33 to 44 ms, once a minute</a:t>
             </a:r>
             <a:endParaRPr lang="en-US" sz="1300" dirty="0"/>
           </a:p>
@@ -11574,49 +11679,7 @@
                 <a:ea typeface="Calibri" pitchFamily="34" charset="-122"/>
                 <a:cs typeface="Calibri" pitchFamily="34" charset="-120"/>
               </a:rPr>
-              <a:t>Flash gaps 33 to 44 ms, once a minute</a:t>
-            </a:r>
-            <a:endParaRPr lang="en-US" sz="1300" dirty="0"/>
-          </a:p>
-          <a:p>
-            <a:pPr marL="228600" indent="-228600">
-              <a:spcAft>
-                <a:spcPts val="800"/>
-              </a:spcAft>
-              <a:buSzPct val="100000"/>
-              <a:buChar char="•"/>
-            </a:pPr>
-            <a:r>
-              <a:rPr lang="en-US" sz="1300" dirty="0">
-                <a:solidFill>
-                  <a:srgbClr val="1B1F24"/>
-                </a:solidFill>
-                <a:latin typeface="Calibri" pitchFamily="34" charset="0"/>
-                <a:ea typeface="Calibri" pitchFamily="34" charset="-122"/>
-                <a:cs typeface="Calibri" pitchFamily="34" charset="-120"/>
-              </a:rPr>
-              <a:t>Uncalibrated: 8% apart (earlier run)</a:t>
-            </a:r>
-            <a:endParaRPr lang="en-US" sz="1300" dirty="0"/>
-          </a:p>
-          <a:p>
-            <a:pPr marL="228600" indent="-228600">
-              <a:spcAft>
-                <a:spcPts val="800"/>
-              </a:spcAft>
-              <a:buSzPct val="100000"/>
-              <a:buChar char="•"/>
-            </a:pPr>
-            <a:r>
-              <a:rPr lang="en-US" sz="1300" dirty="0">
-                <a:solidFill>
-                  <a:srgbClr val="1B1F24"/>
-                </a:solidFill>
-                <a:latin typeface="Calibri" pitchFamily="34" charset="0"/>
-                <a:ea typeface="Calibri" pitchFamily="34" charset="-122"/>
-                <a:cs typeface="Calibri" pitchFamily="34" charset="-120"/>
-              </a:rPr>
-              <a:t>Calibration holds in one orientation</a:t>
+              <a:t>94 Hz filter: lines at 40 to 70 Hz could be images of 136 to 157 Hz; a speed sweep tells them apart</a:t>
             </a:r>
             <a:endParaRPr lang="en-US" sz="1300" dirty="0"/>
           </a:p>
@@ -13406,7 +13469,7 @@
                 <a:ea typeface="Calibri" pitchFamily="34" charset="-122"/>
                 <a:cs typeface="Calibri" pitchFamily="34" charset="-120"/>
               </a:rPr>
-              <a:t>Indoors: network position in 0.7 s, 550 m stated</a:t>
+              <a:t>No fix on the road (19 Oct, no antenna) or in 45 min in the lab (23 Oct)</a:t>
             </a:r>
             <a:endParaRPr lang="en-US" sz="1400" dirty="0"/>
           </a:p>
@@ -13427,7 +13490,7 @@
                 <a:ea typeface="Calibri" pitchFamily="34" charset="-122"/>
                 <a:cs typeface="Calibri" pitchFamily="34" charset="-120"/>
               </a:rPr>
-              <a:t>No fix at all on the first road session</a:t>
+              <a:t>Speed now from a phone's GNSS over its hotspot: a simulated 20 km/h showed as 20 km/h</a:t>
             </a:r>
             <a:endParaRPr lang="en-US" sz="1400" dirty="0"/>
           </a:p>

</xml_diff>

<commit_message>
Title: Embedded Telemetry with Road-Surface Characterisation and Camera-Based Hazard Detection for the TUKZIE Electric Trike (Simon: no comma, trike); report, README, CLAUDE.md, project log D43, deck and poster
</commit_message>
<xml_diff>
--- a/Presentation/SW7_Final_Presentation.pptx
+++ b/Presentation/SW7_Final_Presentation.pptx
@@ -2413,7 +2413,7 @@
                 <a:ea typeface="Calibri" pitchFamily="34" charset="-122"/>
                 <a:cs typeface="Calibri" pitchFamily="34" charset="-120"/>
               </a:rPr>
-              <a:t>Embedded Telemetry, Road-Surface Characterisation</a:t>
+              <a:t>Embedded Telemetry with Road-Surface Characterisation</a:t>
             </a:r>
             <a:endParaRPr lang="en-US" sz="3100" dirty="0"/>
           </a:p>
@@ -2447,7 +2447,7 @@
                 <a:ea typeface="Calibri" pitchFamily="34" charset="-122"/>
                 <a:cs typeface="Calibri" pitchFamily="34" charset="-120"/>
               </a:rPr>
-              <a:t>for the TUKZIE Electric Tricycle</a:t>
+              <a:t>for the TUKZIE Electric Trike</a:t>
             </a:r>
             <a:endParaRPr lang="en-US" sz="3100" dirty="0"/>
           </a:p>

</xml_diff>